<commit_message>
Added images to power-point presentation
</commit_message>
<xml_diff>
--- a/spectral_graph_analysis/spectral_analisys (1).pptx
+++ b/spectral_graph_analysis/spectral_analisys (1).pptx
@@ -21763,6 +21763,36 @@
           <a:chExt cx="0" cy="0"/>
         </a:xfrm>
       </p:grpSpPr>
+      <p:pic>
+        <p:nvPicPr>
+          <p:cNvPr id="7" name="Imagen 6">
+            <a:extLst>
+              <a:ext uri="{FF2B5EF4-FFF2-40B4-BE49-F238E27FC236}">
+                <a16:creationId xmlns:a16="http://schemas.microsoft.com/office/drawing/2014/main" id="{0282E65E-3D52-9D2F-1577-9B80F0527481}"/>
+              </a:ext>
+            </a:extLst>
+          </p:cNvPr>
+          <p:cNvPicPr>
+            <a:picLocks noChangeAspect="1"/>
+          </p:cNvPicPr>
+          <p:nvPr/>
+        </p:nvPicPr>
+        <p:blipFill>
+          <a:blip r:embed="rId2"/>
+          <a:stretch>
+            <a:fillRect/>
+          </a:stretch>
+        </p:blipFill>
+        <p:spPr>
+          <a:xfrm>
+            <a:off x="5401274" y="2873829"/>
+            <a:ext cx="5927064" cy="3488075"/>
+          </a:xfrm>
+          <a:prstGeom prst="rect">
+            <a:avLst/>
+          </a:prstGeom>
+        </p:spPr>
+      </p:pic>
       <p:sp>
         <p:nvSpPr>
           <p:cNvPr id="4" name="Título 3">
@@ -21900,7 +21930,7 @@
           <p:nvPr/>
         </p:nvPicPr>
         <p:blipFill>
-          <a:blip r:embed="rId2"/>
+          <a:blip r:embed="rId3"/>
           <a:srcRect b="63291"/>
           <a:stretch/>
         </p:blipFill>
@@ -21929,7 +21959,7 @@
           <p:nvPr/>
         </p:nvPicPr>
         <p:blipFill>
-          <a:blip r:embed="rId3">
+          <a:blip r:embed="rId4">
             <a:extLst>
               <a:ext uri="{28A0092B-C50C-407E-A947-70E740481C1C}">
                 <a14:useLocalDpi xmlns:a14="http://schemas.microsoft.com/office/drawing/2010/main" val="0"/>
@@ -21943,55 +21973,8 @@
         </p:blipFill>
         <p:spPr bwMode="auto">
           <a:xfrm>
-            <a:off x="8068294" y="425813"/>
-            <a:ext cx="3775363" cy="2765864"/>
-          </a:xfrm>
-          <a:prstGeom prst="rect">
-            <a:avLst/>
-          </a:prstGeom>
-          <a:noFill/>
-          <a:extLst>
-            <a:ext uri="{909E8E84-426E-40DD-AFC4-6F175D3DCCD1}">
-              <a14:hiddenFill xmlns:a14="http://schemas.microsoft.com/office/drawing/2010/main">
-                <a:solidFill>
-                  <a:srgbClr val="FFFFFF"/>
-                </a:solidFill>
-              </a14:hiddenFill>
-            </a:ext>
-          </a:extLst>
-        </p:spPr>
-      </p:pic>
-      <p:pic>
-        <p:nvPicPr>
-          <p:cNvPr id="11266" name="Picture 2">
-            <a:extLst>
-              <a:ext uri="{FF2B5EF4-FFF2-40B4-BE49-F238E27FC236}">
-                <a16:creationId xmlns:a16="http://schemas.microsoft.com/office/drawing/2014/main" id="{DD5EA3D7-4BA6-F31B-52D7-510329AA2AF9}"/>
-              </a:ext>
-            </a:extLst>
-          </p:cNvPr>
-          <p:cNvPicPr>
-            <a:picLocks noChangeAspect="1" noChangeArrowheads="1"/>
-          </p:cNvPicPr>
-          <p:nvPr/>
-        </p:nvPicPr>
-        <p:blipFill>
-          <a:blip r:embed="rId4" cstate="screen">
-            <a:extLst>
-              <a:ext uri="{28A0092B-C50C-407E-A947-70E740481C1C}">
-                <a14:useLocalDpi xmlns:a14="http://schemas.microsoft.com/office/drawing/2010/main" val="0"/>
-              </a:ext>
-            </a:extLst>
-          </a:blip>
-          <a:srcRect/>
-          <a:stretch>
-            <a:fillRect/>
-          </a:stretch>
-        </p:blipFill>
-        <p:spPr bwMode="auto">
-          <a:xfrm>
-            <a:off x="5739493" y="3317456"/>
-            <a:ext cx="5999317" cy="3259003"/>
+            <a:off x="8226571" y="515102"/>
+            <a:ext cx="3374880" cy="2472467"/>
           </a:xfrm>
           <a:prstGeom prst="rect">
             <a:avLst/>
@@ -22282,96 +22265,61 @@
       </p:sp>
       <p:pic>
         <p:nvPicPr>
-          <p:cNvPr id="12290" name="Picture 2">
+          <p:cNvPr id="3" name="Imagen 2">
             <a:extLst>
               <a:ext uri="{FF2B5EF4-FFF2-40B4-BE49-F238E27FC236}">
-                <a16:creationId xmlns:a16="http://schemas.microsoft.com/office/drawing/2014/main" id="{84A07698-F51D-2A31-03AB-5A0774258C56}"/>
+                <a16:creationId xmlns:a16="http://schemas.microsoft.com/office/drawing/2014/main" id="{D1BC74EA-626A-1E1C-D098-E84BB5480DA3}"/>
               </a:ext>
             </a:extLst>
           </p:cNvPr>
           <p:cNvPicPr>
-            <a:picLocks noChangeAspect="1" noChangeArrowheads="1"/>
+            <a:picLocks noChangeAspect="1"/>
           </p:cNvPicPr>
           <p:nvPr/>
         </p:nvPicPr>
         <p:blipFill>
-          <a:blip r:embed="rId2" cstate="screen">
-            <a:extLst>
-              <a:ext uri="{28A0092B-C50C-407E-A947-70E740481C1C}">
-                <a14:useLocalDpi xmlns:a14="http://schemas.microsoft.com/office/drawing/2010/main" val="0"/>
-              </a:ext>
-            </a:extLst>
-          </a:blip>
-          <a:srcRect/>
+          <a:blip r:embed="rId2"/>
           <a:stretch>
             <a:fillRect/>
           </a:stretch>
         </p:blipFill>
-        <p:spPr bwMode="auto">
+        <p:spPr>
           <a:xfrm>
-            <a:off x="3828288" y="1283808"/>
-            <a:ext cx="8262210" cy="4727671"/>
+            <a:off x="97902" y="1137091"/>
+            <a:ext cx="8001070" cy="4989153"/>
           </a:xfrm>
           <a:prstGeom prst="rect">
             <a:avLst/>
           </a:prstGeom>
-          <a:noFill/>
-          <a:extLst>
-            <a:ext uri="{909E8E84-426E-40DD-AFC4-6F175D3DCCD1}">
-              <a14:hiddenFill xmlns:a14="http://schemas.microsoft.com/office/drawing/2010/main">
-                <a:solidFill>
-                  <a:srgbClr val="FFFFFF"/>
-                </a:solidFill>
-              </a14:hiddenFill>
-            </a:ext>
-          </a:extLst>
         </p:spPr>
       </p:pic>
       <p:pic>
         <p:nvPicPr>
-          <p:cNvPr id="12291" name="Picture 3">
+          <p:cNvPr id="6" name="Imagen 5">
             <a:extLst>
               <a:ext uri="{FF2B5EF4-FFF2-40B4-BE49-F238E27FC236}">
-                <a16:creationId xmlns:a16="http://schemas.microsoft.com/office/drawing/2014/main" id="{CA15F007-B4F5-895F-DD22-A9CD37733512}"/>
+                <a16:creationId xmlns:a16="http://schemas.microsoft.com/office/drawing/2014/main" id="{A820C3A8-E0DB-5912-5C7F-464FF6E5FA91}"/>
               </a:ext>
             </a:extLst>
           </p:cNvPr>
           <p:cNvPicPr>
-            <a:picLocks noChangeAspect="1" noChangeArrowheads="1"/>
+            <a:picLocks noChangeAspect="1"/>
           </p:cNvPicPr>
           <p:nvPr/>
         </p:nvPicPr>
         <p:blipFill>
-          <a:blip r:embed="rId3" cstate="screen">
-            <a:extLst>
-              <a:ext uri="{28A0092B-C50C-407E-A947-70E740481C1C}">
-                <a14:useLocalDpi xmlns:a14="http://schemas.microsoft.com/office/drawing/2010/main" val="0"/>
-              </a:ext>
-            </a:extLst>
-          </a:blip>
-          <a:srcRect/>
-          <a:stretch>
-            <a:fillRect/>
-          </a:stretch>
+          <a:blip r:embed="rId3"/>
+          <a:srcRect b="2782"/>
+          <a:stretch/>
         </p:blipFill>
-        <p:spPr bwMode="auto">
+        <p:spPr>
           <a:xfrm>
-            <a:off x="168217" y="2637741"/>
-            <a:ext cx="3475095" cy="3373738"/>
+            <a:off x="8428957" y="1060582"/>
+            <a:ext cx="3337478" cy="4850361"/>
           </a:xfrm>
           <a:prstGeom prst="rect">
             <a:avLst/>
           </a:prstGeom>
-          <a:noFill/>
-          <a:extLst>
-            <a:ext uri="{909E8E84-426E-40DD-AFC4-6F175D3DCCD1}">
-              <a14:hiddenFill xmlns:a14="http://schemas.microsoft.com/office/drawing/2010/main">
-                <a:solidFill>
-                  <a:srgbClr val="FFFFFF"/>
-                </a:solidFill>
-              </a14:hiddenFill>
-            </a:ext>
-          </a:extLst>
         </p:spPr>
       </p:pic>
     </p:spTree>
@@ -22717,8 +22665,8 @@
           </a:p>
         </p:txBody>
       </p:sp>
-      <mc:AlternateContent xmlns:mc="http://schemas.openxmlformats.org/markup-compatibility/2006">
-        <mc:Choice xmlns:a14="http://schemas.microsoft.com/office/drawing/2010/main" Requires="a14">
+      <mc:AlternateContent xmlns:mc="http://schemas.openxmlformats.org/markup-compatibility/2006" xmlns:a14="http://schemas.microsoft.com/office/drawing/2010/main">
+        <mc:Choice Requires="a14">
           <p:sp>
             <p:nvSpPr>
               <p:cNvPr id="8" name="Rectangle 1">
@@ -24603,7 +24551,7 @@
             </p:txBody>
           </p:sp>
         </mc:Choice>
-        <mc:Fallback>
+        <mc:Fallback xmlns="">
           <p:sp>
             <p:nvSpPr>
               <p:cNvPr id="8" name="Rectangle 1">
@@ -29782,17 +29730,6 @@
 </file>
 
 <file path=customXml/item1.xml><?xml version="1.0" encoding="utf-8"?>
-<p:properties xmlns:p="http://schemas.microsoft.com/office/2006/metadata/properties" xmlns:xsi="http://www.w3.org/2001/XMLSchema-instance" xmlns:pc="http://schemas.microsoft.com/office/infopath/2007/PartnerControls">
-  <documentManagement>
-    <TaxCatchAll xmlns="49a340ed-2075-4a8e-ad0c-47f56f22c9bb" xsi:nil="true"/>
-    <lcf76f155ced4ddcb4097134ff3c332f xmlns="a9bfe744-25fc-4eb7-992a-9497b1e5aa87">
-      <Terms xmlns="http://schemas.microsoft.com/office/infopath/2007/PartnerControls"/>
-    </lcf76f155ced4ddcb4097134ff3c332f>
-  </documentManagement>
-</p:properties>
-</file>
-
-<file path=customXml/item2.xml><?xml version="1.0" encoding="utf-8"?>
 <ct:contentTypeSchema xmlns:ct="http://schemas.microsoft.com/office/2006/metadata/contentType" xmlns:ma="http://schemas.microsoft.com/office/2006/metadata/properties/metaAttributes" ct:_="" ma:_="" ma:contentTypeName="Document" ma:contentTypeID="0x010100505EBFD4D5EEC844B66C3A0387734927" ma:contentTypeVersion="18" ma:contentTypeDescription="Create a new document." ma:contentTypeScope="" ma:versionID="30ee85333dd798d83a4360d839a73020">
   <xsd:schema xmlns:xsd="http://www.w3.org/2001/XMLSchema" xmlns:xs="http://www.w3.org/2001/XMLSchema" xmlns:p="http://schemas.microsoft.com/office/2006/metadata/properties" xmlns:ns2="a9bfe744-25fc-4eb7-992a-9497b1e5aa87" xmlns:ns3="49a340ed-2075-4a8e-ad0c-47f56f22c9bb" targetNamespace="http://schemas.microsoft.com/office/2006/metadata/properties" ma:root="true" ma:fieldsID="38301683759f31a9cf157a90a4e84702" ns2:_="" ns3:_="">
     <xsd:import namespace="a9bfe744-25fc-4eb7-992a-9497b1e5aa87"/>
@@ -30047,6 +29984,17 @@
 </ct:contentTypeSchema>
 </file>
 
+<file path=customXml/item2.xml><?xml version="1.0" encoding="utf-8"?>
+<p:properties xmlns:p="http://schemas.microsoft.com/office/2006/metadata/properties" xmlns:xsi="http://www.w3.org/2001/XMLSchema-instance" xmlns:pc="http://schemas.microsoft.com/office/infopath/2007/PartnerControls">
+  <documentManagement>
+    <TaxCatchAll xmlns="49a340ed-2075-4a8e-ad0c-47f56f22c9bb" xsi:nil="true"/>
+    <lcf76f155ced4ddcb4097134ff3c332f xmlns="a9bfe744-25fc-4eb7-992a-9497b1e5aa87">
+      <Terms xmlns="http://schemas.microsoft.com/office/infopath/2007/PartnerControls"/>
+    </lcf76f155ced4ddcb4097134ff3c332f>
+  </documentManagement>
+</p:properties>
+</file>
+
 <file path=customXml/item3.xml><?xml version="1.0" encoding="utf-8"?>
 <?mso-contentType ?>
 <FormTemplates xmlns="http://schemas.microsoft.com/sharepoint/v3/contenttype/forms">
@@ -30057,23 +30005,6 @@
 </file>
 
 <file path=customXml/itemProps1.xml><?xml version="1.0" encoding="utf-8"?>
-<ds:datastoreItem xmlns:ds="http://schemas.openxmlformats.org/officeDocument/2006/customXml" ds:itemID="{5CD580A1-0337-421E-A68D-9AEC6C6DB913}">
-  <ds:schemaRefs>
-    <ds:schemaRef ds:uri="http://schemas.microsoft.com/office/2006/documentManagement/types"/>
-    <ds:schemaRef ds:uri="a9bfe744-25fc-4eb7-992a-9497b1e5aa87"/>
-    <ds:schemaRef ds:uri="http://purl.org/dc/terms/"/>
-    <ds:schemaRef ds:uri="http://purl.org/dc/elements/1.1/"/>
-    <ds:schemaRef ds:uri="http://schemas.microsoft.com/office/2006/metadata/properties"/>
-    <ds:schemaRef ds:uri="http://schemas.microsoft.com/office/infopath/2007/PartnerControls"/>
-    <ds:schemaRef ds:uri="http://schemas.openxmlformats.org/package/2006/metadata/core-properties"/>
-    <ds:schemaRef ds:uri="49a340ed-2075-4a8e-ad0c-47f56f22c9bb"/>
-    <ds:schemaRef ds:uri="http://www.w3.org/XML/1998/namespace"/>
-    <ds:schemaRef ds:uri="http://purl.org/dc/dcmitype/"/>
-  </ds:schemaRefs>
-</ds:datastoreItem>
-</file>
-
-<file path=customXml/itemProps2.xml><?xml version="1.0" encoding="utf-8"?>
 <ds:datastoreItem xmlns:ds="http://schemas.openxmlformats.org/officeDocument/2006/customXml" ds:itemID="{1FFA5205-6258-4762-98D9-8DAFD5974010}">
   <ds:schemaRefs>
     <ds:schemaRef ds:uri="49a340ed-2075-4a8e-ad0c-47f56f22c9bb"/>
@@ -30092,6 +30023,23 @@
 </ds:datastoreItem>
 </file>
 
+<file path=customXml/itemProps2.xml><?xml version="1.0" encoding="utf-8"?>
+<ds:datastoreItem xmlns:ds="http://schemas.openxmlformats.org/officeDocument/2006/customXml" ds:itemID="{5CD580A1-0337-421E-A68D-9AEC6C6DB913}">
+  <ds:schemaRefs>
+    <ds:schemaRef ds:uri="http://schemas.microsoft.com/office/2006/documentManagement/types"/>
+    <ds:schemaRef ds:uri="a9bfe744-25fc-4eb7-992a-9497b1e5aa87"/>
+    <ds:schemaRef ds:uri="http://purl.org/dc/terms/"/>
+    <ds:schemaRef ds:uri="http://purl.org/dc/elements/1.1/"/>
+    <ds:schemaRef ds:uri="http://schemas.microsoft.com/office/2006/metadata/properties"/>
+    <ds:schemaRef ds:uri="http://schemas.microsoft.com/office/infopath/2007/PartnerControls"/>
+    <ds:schemaRef ds:uri="http://schemas.openxmlformats.org/package/2006/metadata/core-properties"/>
+    <ds:schemaRef ds:uri="49a340ed-2075-4a8e-ad0c-47f56f22c9bb"/>
+    <ds:schemaRef ds:uri="http://www.w3.org/XML/1998/namespace"/>
+    <ds:schemaRef ds:uri="http://purl.org/dc/dcmitype/"/>
+  </ds:schemaRefs>
+</ds:datastoreItem>
+</file>
+
 <file path=customXml/itemProps3.xml><?xml version="1.0" encoding="utf-8"?>
 <ds:datastoreItem xmlns:ds="http://schemas.openxmlformats.org/officeDocument/2006/customXml" ds:itemID="{B7CDBEA0-9AC9-4D91-93D6-3374F0D1B3B6}">
   <ds:schemaRefs>

</xml_diff>